<commit_message>
edits before class done
</commit_message>
<xml_diff>
--- a/slides/08-week8/02-thur/UrbanEconomicsIntrotoDiscrimination.pptx
+++ b/slides/08-week8/02-thur/UrbanEconomicsIntrotoDiscrimination.pptx
@@ -131,6 +131,11 @@
       </a:defRPr>
     </a:lvl9pPr>
   </p:defaultTextStyle>
+  <p:extLst>
+    <p:ext uri="{EFAFB233-063F-42B5-8137-9DF3F51BA10A}">
+      <p15:sldGuideLst xmlns:p15="http://schemas.microsoft.com/office/powerpoint/2012/main"/>
+    </p:ext>
+  </p:extLst>
 </p:presentation>
 </file>
 
@@ -7204,6 +7209,26 @@
           </a:bodyPr>
           <a:lstStyle/>
           <a:p>
+            <a:pPr marL="0" indent="0">
+              <a:lnSpc>
+                <a:spcPct val="90000"/>
+              </a:lnSpc>
+              <a:spcBef>
+                <a:spcPts val="1001"/>
+              </a:spcBef>
+              <a:buClr>
+                <a:srgbClr val="404040"/>
+              </a:buClr>
+              <a:buNone/>
+            </a:pPr>
+            <a:endParaRPr lang="en-US" sz="2400" b="0" strike="noStrike" spc="-1" dirty="0">
+              <a:solidFill>
+                <a:srgbClr val="404040"/>
+              </a:solidFill>
+              <a:latin typeface="Century Gothic"/>
+            </a:endParaRPr>
+          </a:p>
+          <a:p>
             <a:pPr marL="228600" indent="-228600">
               <a:lnSpc>
                 <a:spcPct val="90000"/>
@@ -7218,13 +7243,13 @@
               <a:buChar char="•"/>
             </a:pPr>
             <a:r>
-              <a:rPr lang="en-US" sz="2400" b="0" strike="noStrike" spc="-1">
+              <a:rPr lang="en-US" sz="2400" b="0" strike="noStrike" spc="-1" dirty="0">
                 <a:solidFill>
                   <a:srgbClr val="404040"/>
                 </a:solidFill>
                 <a:latin typeface="Century Gothic"/>
               </a:rPr>
-              <a:t>You’ll hear later in the course about a research project I am working on that quantifies sexual orientation discrimination in access to mortgage loans.</a:t>
+              <a:t>One concern we have is that mortgage loan originators – who people work with to get mortgages – may statistically discriminate against applicants based on perceptions of their credit worthiness.</a:t>
             </a:r>
           </a:p>
           <a:p>
@@ -7242,31 +7267,7 @@
               <a:buChar char="•"/>
             </a:pPr>
             <a:r>
-              <a:rPr lang="en-US" sz="2400" b="0" strike="noStrike" spc="-1">
-                <a:solidFill>
-                  <a:srgbClr val="404040"/>
-                </a:solidFill>
-                <a:latin typeface="Century Gothic"/>
-              </a:rPr>
-              <a:t>One concern we have is that mortgage loan originators – who people work with to get mortgages – may statistically discriminate against applicants based on perceptions of their credit worthiness.</a:t>
-            </a:r>
-          </a:p>
-          <a:p>
-            <a:pPr marL="228600" indent="-228600">
-              <a:lnSpc>
-                <a:spcPct val="90000"/>
-              </a:lnSpc>
-              <a:spcBef>
-                <a:spcPts val="1001"/>
-              </a:spcBef>
-              <a:buClr>
-                <a:srgbClr val="404040"/>
-              </a:buClr>
-              <a:buFont typeface="Arial"/>
-              <a:buChar char="•"/>
-            </a:pPr>
-            <a:r>
-              <a:rPr lang="en-US" sz="2400" b="0" strike="noStrike" spc="-1">
+              <a:rPr lang="en-US" sz="2400" b="0" strike="noStrike" spc="-1" dirty="0">
                 <a:solidFill>
                   <a:srgbClr val="404040"/>
                 </a:solidFill>

</xml_diff>